<commit_message>
Getting Started with Yajra Datatable
</commit_message>
<xml_diff>
--- a/.lessons/32 Fundamental Localization/2 Change Translation Depending On Route/1.pptx
+++ b/.lessons/32 Fundamental Localization/2 Change Translation Depending On Route/1.pptx
@@ -12814,7 +12814,7 @@
         <p:spPr>
           <a:xfrm>
             <a:off x="217715" y="255046"/>
-            <a:ext cx="6500326" cy="2455929"/>
+            <a:ext cx="6500326" cy="3956339"/>
           </a:xfrm>
           <a:prstGeom prst="rect">
             <a:avLst/>
@@ -12995,6 +12995,94 @@
                 <a:latin typeface="Arial" panose="020B0604020202020204" pitchFamily="34" charset="0"/>
               </a:rPr>
               <a:t>` kontrollerində bəzi dəyişikliklər edə bilərsiniz.</a:t>
+            </a:r>
+          </a:p>
+          <a:p>
+            <a:pPr>
+              <a:lnSpc>
+                <a:spcPct val="150000"/>
+              </a:lnSpc>
+              <a:buNone/>
+            </a:pPr>
+            <a:endParaRPr kumimoji="0" lang="az-Latn-AZ" altLang="en-US" sz="1300" b="0" i="0" u="none" strike="noStrike" cap="none" normalizeH="0" baseline="0">
+              <a:ln>
+                <a:noFill/>
+              </a:ln>
+              <a:solidFill>
+                <a:schemeClr val="tx1"/>
+              </a:solidFill>
+              <a:effectLst/>
+              <a:latin typeface="Arial" panose="020B0604020202020204" pitchFamily="34" charset="0"/>
+            </a:endParaRPr>
+          </a:p>
+          <a:p>
+            <a:pPr>
+              <a:lnSpc>
+                <a:spcPct val="150000"/>
+              </a:lnSpc>
+              <a:buNone/>
+            </a:pPr>
+            <a:endParaRPr lang="az-Latn-AZ" altLang="en-US" sz="1300">
+              <a:latin typeface="Arial" panose="020B0604020202020204" pitchFamily="34" charset="0"/>
+            </a:endParaRPr>
+          </a:p>
+          <a:p>
+            <a:pPr>
+              <a:lnSpc>
+                <a:spcPct val="150000"/>
+              </a:lnSpc>
+              <a:buNone/>
+            </a:pPr>
+            <a:endParaRPr kumimoji="0" lang="az-Latn-AZ" altLang="en-US" sz="1300" b="0" i="0" u="none" strike="noStrike" cap="none" normalizeH="0" baseline="0">
+              <a:ln>
+                <a:noFill/>
+              </a:ln>
+              <a:solidFill>
+                <a:schemeClr val="tx1"/>
+              </a:solidFill>
+              <a:effectLst/>
+              <a:latin typeface="Arial" panose="020B0604020202020204" pitchFamily="34" charset="0"/>
+            </a:endParaRPr>
+          </a:p>
+          <a:p>
+            <a:pPr>
+              <a:lnSpc>
+                <a:spcPct val="150000"/>
+              </a:lnSpc>
+              <a:buNone/>
+            </a:pPr>
+            <a:r>
+              <a:rPr lang="en-US" altLang="en-US" sz="1300">
+                <a:latin typeface="Arial" panose="020B0604020202020204" pitchFamily="34" charset="0"/>
+              </a:rPr>
+              <a:t>gmail: test@gmail.com</a:t>
+            </a:r>
+          </a:p>
+          <a:p>
+            <a:pPr>
+              <a:lnSpc>
+                <a:spcPct val="150000"/>
+              </a:lnSpc>
+              <a:buNone/>
+            </a:pPr>
+            <a:r>
+              <a:rPr kumimoji="0" lang="en-US" altLang="en-US" sz="1300" b="0" i="0" u="none" strike="noStrike" cap="none" normalizeH="0" baseline="0">
+                <a:ln>
+                  <a:noFill/>
+                </a:ln>
+                <a:solidFill>
+                  <a:schemeClr val="tx1"/>
+                </a:solidFill>
+                <a:effectLst/>
+                <a:latin typeface="Arial" panose="020B0604020202020204" pitchFamily="34" charset="0"/>
+              </a:rPr>
+              <a:t>pass</a:t>
+            </a:r>
+            <a:r>
+              <a:rPr lang="en-US" altLang="en-US" sz="1300">
+                <a:latin typeface="Arial" panose="020B0604020202020204" pitchFamily="34" charset="0"/>
+              </a:rPr>
+              <a:t>: 12345678</a:t>
             </a:r>
             <a:endParaRPr kumimoji="0" lang="en-US" altLang="en-US" sz="1300" b="0" i="0" u="none" strike="noStrike" cap="none" normalizeH="0" baseline="0">
               <a:ln>

</xml_diff>